<commit_message>
feat: finalize smart collect submission scope
</commit_message>
<xml_diff>
--- a/presentation/AI_Master_최종발표_이형진_08079.pptx
+++ b/presentation/AI_Master_최종발표_이형진_08079.pptx
@@ -391,7 +391,7 @@
           </a:p>
           <a:p>
             <a:r>
-              <a:t>성과는 세 수치입니다. ① 오류 검출 F1 100%, 오탐·미탐 0 ② 46행을 0.08초, 초당 549행 처리 ③ 자가교정으로 재작업 60% 감소. 한 문장으로, LangGraph에 Tree of Thoughts와 Self-Correction을 더해 취합 검증을 F1 100%·재현성 표준편차 0으로 자동화했습니다.</a:t>
+              <a:t>성과는 세 수치입니다. ① 오류 검출 F1 100%, 오탐·미탐 0 ② 46행을 약 0.08초, 초당 500행 이상 처리 ③ 자가교정으로 재작업 60% 감소. 한 문장으로, LangGraph에 Tree of Thoughts와 Self-Correction을 더해 취합 검증을 F1 100%·재현성 표준편차 0으로 자동화했습니다.</a:t>
             </a:r>
           </a:p>
         </p:txBody>
@@ -487,7 +487,7 @@
           </a:p>
           <a:p>
             <a:r>
-              <a:t>기술 선택 셋. ① LangGraph — 단일 에이전트·단순 Chain으로는 분석·검증·교정·보고의 책임 분리와 상태 관리가 어렵습니다. 조건분기로 6개 노드를 오케스트레이션했습니다.</a:t>
+              <a:t>기술 선택 셋. ① LangGraph — 단일 에이전트·단순 Chain으로는 분석·검증·교정·보고의 책임 분리와 상태 관리가 어렵습니다. 조건분기로 7개 노드를 오케스트레이션했습니다.</a:t>
             </a:r>
           </a:p>
           <a:p>
@@ -1248,7 +1248,7 @@
                 <a:ea typeface="Arial" pitchFamily="34" charset="-122"/>
                 <a:cs typeface="Arial" pitchFamily="34" charset="-120"/>
               </a:rPr>
-              <a:t>[멘토님 성함]</a:t>
+              <a:t>AI Master 멘토</a:t>
             </a:r>
             <a:endParaRPr lang="en-US" sz="1300" dirty="0"/>
           </a:p>
@@ -2296,7 +2296,7 @@
                 <a:ea typeface="Arial" pitchFamily="34" charset="-122"/>
                 <a:cs typeface="Arial" pitchFamily="34" charset="-120"/>
               </a:rPr>
-              <a:t>0.08초</a:t>
+              <a:t>약 0.08초</a:t>
             </a:r>
             <a:endParaRPr lang="en-US" dirty="0"/>
           </a:p>
@@ -2335,7 +2335,7 @@
                 <a:ea typeface="Arial" pitchFamily="34" charset="-122"/>
                 <a:cs typeface="Arial" pitchFamily="34" charset="-120"/>
               </a:rPr>
-              <a:t>549행/초</a:t>
+              <a:t>500행+/초</a:t>
             </a:r>
             <a:r>
               <a:rPr lang="en-US" altLang="ko-KR" sz="800" dirty="0">
@@ -3470,7 +3470,7 @@
                 <a:ea typeface="Arial" pitchFamily="34" charset="-122"/>
                 <a:cs typeface="Arial" pitchFamily="34" charset="-120"/>
               </a:rPr>
-              <a:t>State 기반 조건분기로 6개 노드를 오케스트레이션하고 RAG 필요 시에만 분기합니다.</a:t>
+              <a:t>State 기반 조건분기로 7개 노드를 오케스트레이션하고, 기준 검색은 선택 기능으로 분리했습니다.</a:t>
             </a:r>
             <a:endParaRPr lang="en-US" sz="850" dirty="0"/>
           </a:p>

</xml_diff>